<commit_message>
Recolour Dec-26 items as Release 1 in roadmap and tracker
Co-Authored-By: Claude Opus 5.5 <noreply@anthropic.com>
Claude-Session: https://claude.ai/code/session_01YRFgXpWYZpZNdiR4z24WSz
</commit_message>
<xml_diff>
--- a/ManageEngine_Technical_Delivery_Roadmap_v3.pptx
+++ b/ManageEngine_Technical_Delivery_Roadmap_v3.pptx
@@ -107,7 +107,7 @@
   <p:extLst>
     <p:ext uri="{521415D9-36F7-43E2-AB2F-B90AF26B5E84}">
       <p14:sectionLst xmlns:p14="http://schemas.microsoft.com/office/powerpoint/2010/main">
-        <p14:section name="Roadmap" id="{6ec3b2b4-51f6-0f10-829c-9bb5e232d4d0}">
+        <p14:section name="Roadmap" id="{9dc2753c-96d6-f8e0-6414-7bcc3c789468}">
           <p14:sldIdLst>
             <p14:sldId id="256"/>
           </p14:sldIdLst>
@@ -516,7 +516,7 @@
           <a:p>
             <a:r>
               <a:rPr lang="en-US" dirty="0"/>
-              <a:t>Source: ManageEngine_Interface_Tracker_v4.xlsx. Each interface is placed in the month of its planned End date and coloured by its Release column. Phase 1 = Release 1 (Oct–Dec-26); Phase 2 = Releases 2 and 3 (Jan–Jun-27). Milestone markers sit at their date within the month. Roadmap v2 edits: Intune, SCCM, Lansweeper, NTT CMDB and HP (now under Vendor &amp; External Services) finish Dec-26 as Release 2 items; VMware vSphere, Azure Resource Graph and Azure API Management finish Jan-27; milestones at month end. Phase = TBD items sit in the Future / TBD column. Updated per 28-Oct-2026 call with Jacinta Undy: release windows realigned; agent/agentless pilot (Nov) and rollout (Dec, contingency Jan) clubbed; Tenable and NetBox moved to TBD; CMDB/asset-list feeds (Intune, SCCM, Lansweeper, NTT CMDB) moved to start of Release 2 (Jan-27); Golden Asset Record milestone added for end of Jan-27 (contingency Feb). The Golden Asset Record depends on the asset integrations, which depend on the full agent/agentless rollout.</a:t>
+              <a:t>Source: ManageEngine_Interface_Tracker_v4.xlsx. Each interface is placed in the month of its planned End date and coloured by its Release column. Phase 1 = Release 1 (Oct–Dec-26); Phase 2 = Releases 2 and 3 (Jan–Jun-27). Milestone markers sit at their date within the month. Roadmap v2 edits: Intune, SCCM, Lansweeper, NTT CMDB and HP (now under Vendor &amp; External Services) finish Dec-26 as Release 1 items; VMware vSphere, Azure Resource Graph and Azure API Management finish Jan-27; milestones at month end. Phase = TBD items sit in the Future / TBD column. Updated per 28-Oct-2026 call with Jacinta Undy: release windows realigned; agent/agentless pilot (Nov) and rollout (Dec, contingency Jan) clubbed; Tenable and NetBox moved to TBD; CMDB/asset-list feeds (Intune, SCCM, Lansweeper, NTT CMDB) moved to start of Release 2 (Jan-27); Golden Asset Record milestone added for end of Jan-27 (contingency Feb). The Golden Asset Record depends on the asset integrations, which depend on the full agent/agentless rollout.</a:t>
             </a:r>
             <a:endParaRPr lang="en-US" dirty="0"/>
           </a:p>
@@ -3066,7 +3066,7 @@
       </p:sp>
       <p:sp>
         <p:nvSpPr>
-          <p:cNvPr id="59" name="Intune (Release 2)"/>
+          <p:cNvPr id="59" name="Intune (Release 1)"/>
           <p:cNvSpPr/>
           <p:nvPr/>
         </p:nvSpPr>
@@ -3081,11 +3081,11 @@
             </a:avLst>
           </a:prstGeom>
           <a:solidFill>
-            <a:srgbClr val="A8DCD1"/>
+            <a:srgbClr val="A9CBF2"/>
           </a:solidFill>
           <a:ln w="6350">
             <a:solidFill>
-              <a:srgbClr val="A8DCD1"/>
+              <a:srgbClr val="A9CBF2"/>
             </a:solidFill>
           </a:ln>
         </p:spPr>
@@ -3099,7 +3099,7 @@
             <a:r>
               <a:rPr lang="en-US" sz="850" dirty="0">
                 <a:solidFill>
-                  <a:srgbClr val="0F3F38"/>
+                  <a:srgbClr val="14285A"/>
                 </a:solidFill>
                 <a:latin typeface="Calibri" pitchFamily="34" charset="0"/>
                 <a:ea typeface="Calibri" pitchFamily="34" charset="-122"/>
@@ -3113,7 +3113,7 @@
       </p:sp>
       <p:sp>
         <p:nvSpPr>
-          <p:cNvPr id="60" name="SCCM (Release 2)"/>
+          <p:cNvPr id="60" name="SCCM (Release 1)"/>
           <p:cNvSpPr/>
           <p:nvPr/>
         </p:nvSpPr>
@@ -3128,11 +3128,11 @@
             </a:avLst>
           </a:prstGeom>
           <a:solidFill>
-            <a:srgbClr val="A8DCD1"/>
+            <a:srgbClr val="A9CBF2"/>
           </a:solidFill>
           <a:ln w="6350">
             <a:solidFill>
-              <a:srgbClr val="A8DCD1"/>
+              <a:srgbClr val="A9CBF2"/>
             </a:solidFill>
           </a:ln>
         </p:spPr>
@@ -3146,7 +3146,7 @@
             <a:r>
               <a:rPr lang="en-US" sz="850" dirty="0">
                 <a:solidFill>
-                  <a:srgbClr val="0F3F38"/>
+                  <a:srgbClr val="14285A"/>
                 </a:solidFill>
                 <a:latin typeface="Calibri" pitchFamily="34" charset="0"/>
                 <a:ea typeface="Calibri" pitchFamily="34" charset="-122"/>
@@ -3160,7 +3160,7 @@
       </p:sp>
       <p:sp>
         <p:nvSpPr>
-          <p:cNvPr id="61" name="Lansweeper (Release 2)"/>
+          <p:cNvPr id="61" name="Lansweeper (Release 1)"/>
           <p:cNvSpPr/>
           <p:nvPr/>
         </p:nvSpPr>
@@ -3175,11 +3175,11 @@
             </a:avLst>
           </a:prstGeom>
           <a:solidFill>
-            <a:srgbClr val="A8DCD1"/>
+            <a:srgbClr val="A9CBF2"/>
           </a:solidFill>
           <a:ln w="6350">
             <a:solidFill>
-              <a:srgbClr val="A8DCD1"/>
+              <a:srgbClr val="A9CBF2"/>
             </a:solidFill>
           </a:ln>
         </p:spPr>
@@ -3193,7 +3193,7 @@
             <a:r>
               <a:rPr lang="en-US" sz="850" dirty="0">
                 <a:solidFill>
-                  <a:srgbClr val="0F3F38"/>
+                  <a:srgbClr val="14285A"/>
                 </a:solidFill>
                 <a:latin typeface="Calibri" pitchFamily="34" charset="0"/>
                 <a:ea typeface="Calibri" pitchFamily="34" charset="-122"/>
@@ -4253,7 +4253,7 @@
       </p:sp>
       <p:sp>
         <p:nvSpPr>
-          <p:cNvPr id="88" name="NTT CMDB (Release 2)"/>
+          <p:cNvPr id="88" name="NTT CMDB (Release 1)"/>
           <p:cNvSpPr/>
           <p:nvPr/>
         </p:nvSpPr>
@@ -4268,11 +4268,11 @@
             </a:avLst>
           </a:prstGeom>
           <a:solidFill>
-            <a:srgbClr val="A8DCD1"/>
+            <a:srgbClr val="A9CBF2"/>
           </a:solidFill>
           <a:ln w="6350">
             <a:solidFill>
-              <a:srgbClr val="A8DCD1"/>
+              <a:srgbClr val="A9CBF2"/>
             </a:solidFill>
           </a:ln>
         </p:spPr>
@@ -4286,7 +4286,7 @@
             <a:r>
               <a:rPr lang="en-US" sz="850" dirty="0">
                 <a:solidFill>
-                  <a:srgbClr val="0F3F38"/>
+                  <a:srgbClr val="14285A"/>
                 </a:solidFill>
                 <a:latin typeface="Calibri" pitchFamily="34" charset="0"/>
                 <a:ea typeface="Calibri" pitchFamily="34" charset="-122"/>
@@ -4300,7 +4300,7 @@
       </p:sp>
       <p:sp>
         <p:nvSpPr>
-          <p:cNvPr id="89" name="HP (Release 2)"/>
+          <p:cNvPr id="89" name="HP (Release 1)"/>
           <p:cNvSpPr/>
           <p:nvPr/>
         </p:nvSpPr>
@@ -4315,11 +4315,11 @@
             </a:avLst>
           </a:prstGeom>
           <a:solidFill>
-            <a:srgbClr val="A8DCD1"/>
+            <a:srgbClr val="A9CBF2"/>
           </a:solidFill>
           <a:ln w="6350">
             <a:solidFill>
-              <a:srgbClr val="A8DCD1"/>
+              <a:srgbClr val="A9CBF2"/>
             </a:solidFill>
           </a:ln>
         </p:spPr>
@@ -4333,7 +4333,7 @@
             <a:r>
               <a:rPr lang="en-US" sz="850" dirty="0">
                 <a:solidFill>
-                  <a:srgbClr val="0F3F38"/>
+                  <a:srgbClr val="14285A"/>
                 </a:solidFill>
                 <a:latin typeface="Calibri" pitchFamily="34" charset="0"/>
                 <a:ea typeface="Calibri" pitchFamily="34" charset="-122"/>

</xml_diff>